<commit_message>
figure and lab doc update
</commit_message>
<xml_diff>
--- a/RVfpga/RVfpgaEL2/RVfpga_NexysVideo-NoDDR/Documents/Figures_GSG/RVfpgaEL2-Tools.pptx
+++ b/RVfpga/RVfpgaEL2/RVfpga_NexysVideo-NoDDR/Documents/Figures_GSG/RVfpgaEL2-Tools.pptx
@@ -262,7 +262,7 @@
           <a:p>
             <a:fld id="{2B2E9F51-2256-4233-B76C-11992B86829D}" type="datetimeFigureOut">
               <a:rPr lang="en-US" smtClean="0"/>
-              <a:t>8/18/2023</a:t>
+              <a:t>10/12/2025</a:t>
             </a:fld>
             <a:endParaRPr lang="en-US"/>
           </a:p>
@@ -460,7 +460,7 @@
           <a:p>
             <a:fld id="{2B2E9F51-2256-4233-B76C-11992B86829D}" type="datetimeFigureOut">
               <a:rPr lang="en-US" smtClean="0"/>
-              <a:t>8/18/2023</a:t>
+              <a:t>10/12/2025</a:t>
             </a:fld>
             <a:endParaRPr lang="en-US"/>
           </a:p>
@@ -668,7 +668,7 @@
           <a:p>
             <a:fld id="{2B2E9F51-2256-4233-B76C-11992B86829D}" type="datetimeFigureOut">
               <a:rPr lang="en-US" smtClean="0"/>
-              <a:t>8/18/2023</a:t>
+              <a:t>10/12/2025</a:t>
             </a:fld>
             <a:endParaRPr lang="en-US"/>
           </a:p>
@@ -866,7 +866,7 @@
           <a:p>
             <a:fld id="{2B2E9F51-2256-4233-B76C-11992B86829D}" type="datetimeFigureOut">
               <a:rPr lang="en-US" smtClean="0"/>
-              <a:t>8/18/2023</a:t>
+              <a:t>10/12/2025</a:t>
             </a:fld>
             <a:endParaRPr lang="en-US"/>
           </a:p>
@@ -1141,7 +1141,7 @@
           <a:p>
             <a:fld id="{2B2E9F51-2256-4233-B76C-11992B86829D}" type="datetimeFigureOut">
               <a:rPr lang="en-US" smtClean="0"/>
-              <a:t>8/18/2023</a:t>
+              <a:t>10/12/2025</a:t>
             </a:fld>
             <a:endParaRPr lang="en-US"/>
           </a:p>
@@ -1406,7 +1406,7 @@
           <a:p>
             <a:fld id="{2B2E9F51-2256-4233-B76C-11992B86829D}" type="datetimeFigureOut">
               <a:rPr lang="en-US" smtClean="0"/>
-              <a:t>8/18/2023</a:t>
+              <a:t>10/12/2025</a:t>
             </a:fld>
             <a:endParaRPr lang="en-US"/>
           </a:p>
@@ -1818,7 +1818,7 @@
           <a:p>
             <a:fld id="{2B2E9F51-2256-4233-B76C-11992B86829D}" type="datetimeFigureOut">
               <a:rPr lang="en-US" smtClean="0"/>
-              <a:t>8/18/2023</a:t>
+              <a:t>10/12/2025</a:t>
             </a:fld>
             <a:endParaRPr lang="en-US"/>
           </a:p>
@@ -1959,7 +1959,7 @@
           <a:p>
             <a:fld id="{2B2E9F51-2256-4233-B76C-11992B86829D}" type="datetimeFigureOut">
               <a:rPr lang="en-US" smtClean="0"/>
-              <a:t>8/18/2023</a:t>
+              <a:t>10/12/2025</a:t>
             </a:fld>
             <a:endParaRPr lang="en-US"/>
           </a:p>
@@ -2072,7 +2072,7 @@
           <a:p>
             <a:fld id="{2B2E9F51-2256-4233-B76C-11992B86829D}" type="datetimeFigureOut">
               <a:rPr lang="en-US" smtClean="0"/>
-              <a:t>8/18/2023</a:t>
+              <a:t>10/12/2025</a:t>
             </a:fld>
             <a:endParaRPr lang="en-US"/>
           </a:p>
@@ -2383,7 +2383,7 @@
           <a:p>
             <a:fld id="{2B2E9F51-2256-4233-B76C-11992B86829D}" type="datetimeFigureOut">
               <a:rPr lang="en-US" smtClean="0"/>
-              <a:t>8/18/2023</a:t>
+              <a:t>10/12/2025</a:t>
             </a:fld>
             <a:endParaRPr lang="en-US"/>
           </a:p>
@@ -2671,7 +2671,7 @@
           <a:p>
             <a:fld id="{2B2E9F51-2256-4233-B76C-11992B86829D}" type="datetimeFigureOut">
               <a:rPr lang="en-US" smtClean="0"/>
-              <a:t>8/18/2023</a:t>
+              <a:t>10/12/2025</a:t>
             </a:fld>
             <a:endParaRPr lang="en-US"/>
           </a:p>
@@ -2912,7 +2912,7 @@
           <a:p>
             <a:fld id="{2B2E9F51-2256-4233-B76C-11992B86829D}" type="datetimeFigureOut">
               <a:rPr lang="en-US" smtClean="0"/>
-              <a:t>8/18/2023</a:t>
+              <a:t>10/12/2025</a:t>
             </a:fld>
             <a:endParaRPr lang="en-US"/>
           </a:p>
@@ -3628,7 +3628,7 @@
         </p:sp>
         <p:pic>
           <p:nvPicPr>
-            <p:cNvPr id="22" name="Picture 21" descr="A picture containing text, electronics, circuit&#10;&#10;Description automatically generated">
+            <p:cNvPr id="22" name="Picture 21">
               <a:extLst>
                 <a:ext uri="{FF2B5EF4-FFF2-40B4-BE49-F238E27FC236}">
                   <a16:creationId xmlns:a16="http://schemas.microsoft.com/office/drawing/2014/main" id="{359586E1-23CE-448B-ECB5-6902B325DD1A}"/>
@@ -3648,14 +3648,13 @@
                 </a:ext>
               </a:extLst>
             </a:blip>
-            <a:stretch>
-              <a:fillRect/>
-            </a:stretch>
+            <a:srcRect/>
+            <a:stretch/>
           </p:blipFill>
           <p:spPr>
             <a:xfrm>
-              <a:off x="2847582" y="503018"/>
-              <a:ext cx="1222929" cy="1139770"/>
+              <a:off x="2847582" y="518509"/>
+              <a:ext cx="1222929" cy="1108788"/>
             </a:xfrm>
             <a:prstGeom prst="rect">
               <a:avLst/>
@@ -3756,7 +3755,7 @@
         </p:pic>
         <p:pic>
           <p:nvPicPr>
-            <p:cNvPr id="38" name="Picture 37" descr="Graphical user interface&#10;&#10;Description automatically generated">
+            <p:cNvPr id="38" name="Picture 37">
               <a:extLst>
                 <a:ext uri="{FF2B5EF4-FFF2-40B4-BE49-F238E27FC236}">
                   <a16:creationId xmlns:a16="http://schemas.microsoft.com/office/drawing/2014/main" id="{4140DE8C-ED37-BCE2-0C49-DD54F18FBE66}"/>
@@ -3769,21 +3768,20 @@
             <p:nvPr/>
           </p:nvPicPr>
           <p:blipFill>
-            <a:blip r:embed="rId4">
+            <a:blip r:embed="rId2">
               <a:extLst>
                 <a:ext uri="{28A0092B-C50C-407E-A947-70E740481C1C}">
                   <a14:useLocalDpi xmlns:a14="http://schemas.microsoft.com/office/drawing/2010/main" val="0"/>
                 </a:ext>
               </a:extLst>
             </a:blip>
-            <a:stretch>
-              <a:fillRect/>
-            </a:stretch>
+            <a:srcRect/>
+            <a:stretch/>
           </p:blipFill>
           <p:spPr>
             <a:xfrm>
-              <a:off x="183895" y="1142603"/>
-              <a:ext cx="2246951" cy="2235417"/>
+              <a:off x="183895" y="1241694"/>
+              <a:ext cx="2246951" cy="2037234"/>
             </a:xfrm>
             <a:prstGeom prst="rect">
               <a:avLst/>
@@ -4626,7 +4624,7 @@
             <p:nvPr/>
           </p:nvPicPr>
           <p:blipFill>
-            <a:blip r:embed="rId5">
+            <a:blip r:embed="rId4">
               <a:extLst>
                 <a:ext uri="{28A0092B-C50C-407E-A947-70E740481C1C}">
                   <a14:useLocalDpi xmlns:a14="http://schemas.microsoft.com/office/drawing/2010/main" val="0"/>
@@ -4667,7 +4665,7 @@
             <p:nvPr/>
           </p:nvPicPr>
           <p:blipFill>
-            <a:blip r:embed="rId6">
+            <a:blip r:embed="rId5">
               <a:extLst>
                 <a:ext uri="{28A0092B-C50C-407E-A947-70E740481C1C}">
                   <a14:useLocalDpi xmlns:a14="http://schemas.microsoft.com/office/drawing/2010/main" val="0"/>

</xml_diff>